<commit_message>
ultimos ajustes no power point e código
</commit_message>
<xml_diff>
--- a/docs/ClickEscola_-_API_Gateway_e_Microsservicos.pptx
+++ b/docs/ClickEscola_-_API_Gateway_e_Microsservicos.pptx
@@ -5129,6 +5129,30 @@
           </a:p>
         </p:txBody>
       </p:sp>
+      <p:pic>
+        <p:nvPicPr>
+          <p:cNvPr id="21" name="Image Resiliencia" descr="Diagrama: cliente, API Gateway NGINX e servicos com respostas 200 e 503 (isolamento de falhas)"/>
+          <p:cNvPicPr>
+            <a:picLocks noChangeAspect="1"/>
+          </p:cNvPicPr>
+          <p:nvPr/>
+        </p:nvPicPr>
+        <p:blipFill>
+          <a:blip r:embed="rId3"/>
+          <a:stretch>
+            <a:fillRect/>
+          </a:stretch>
+        </p:blipFill>
+        <p:spPr>
+          <a:xfrm>
+            <a:off x="9427350" y="4450889"/>
+            <a:ext cx="7796250" cy="3996027"/>
+          </a:xfrm>
+          <a:prstGeom prst="rect">
+            <a:avLst/>
+          </a:prstGeom>
+        </p:spPr>
+      </p:pic>
     </p:spTree>
   </p:cSld>
   <p:clrMapOvr>

</xml_diff>